<commit_message>
Clarify proposed paid review in pitch
</commit_message>
<xml_diff>
--- a/docs/coursework/pitch.pptx
+++ b/docs/coursework/pitch.pptx
@@ -2,15 +2,15 @@
 <file path=ppt/presentation.xml><?xml version="1.0" encoding="utf-8"?>
 <p:presentation xmlns:p="http://schemas.openxmlformats.org/presentationml/2006/main">
   <p:sldMasterIdLst>
-    <p:sldMasterId xmlns:r="http://schemas.openxmlformats.org/officeDocument/2006/relationships" id="2147483648" r:id="R7d9d6b1311a44c23"/>
+    <p:sldMasterId xmlns:r="http://schemas.openxmlformats.org/officeDocument/2006/relationships" id="2147483648" r:id="R5faabbee1c7442a6"/>
   </p:sldMasterIdLst>
   <p:notesMasterIdLst>
-    <p:notesMasterId xmlns:r="http://schemas.openxmlformats.org/officeDocument/2006/relationships" r:id="R3049cd2c47244308"/>
+    <p:notesMasterId xmlns:r="http://schemas.openxmlformats.org/officeDocument/2006/relationships" r:id="R1db2405fc6614852"/>
   </p:notesMasterIdLst>
   <p:sldIdLst>
-    <p:sldId xmlns:r="http://schemas.openxmlformats.org/officeDocument/2006/relationships" id="256" r:id="R676b1826acf84386"/>
-    <p:sldId xmlns:r="http://schemas.openxmlformats.org/officeDocument/2006/relationships" id="257" r:id="Rd8ac5338e8074a13"/>
-    <p:sldId xmlns:r="http://schemas.openxmlformats.org/officeDocument/2006/relationships" id="258" r:id="Rfdb994fa104f45cd"/>
+    <p:sldId xmlns:r="http://schemas.openxmlformats.org/officeDocument/2006/relationships" id="256" r:id="Rea99b1f01b4f4c96"/>
+    <p:sldId xmlns:r="http://schemas.openxmlformats.org/officeDocument/2006/relationships" id="257" r:id="R6e506ccfb844453a"/>
+    <p:sldId xmlns:r="http://schemas.openxmlformats.org/officeDocument/2006/relationships" id="258" r:id="Ra7d530e4c746410e"/>
   </p:sldIdLst>
   <p:sldSz cx="12192000" cy="6858000"/>
   <p:notesSz cx="6858000" cy="9144000"/>
@@ -444,7 +444,7 @@
           <a:lstStyle xmlns:a="http://schemas.openxmlformats.org/drawingml/2006/main"/>
           <a:p xmlns:a="http://schemas.openxmlformats.org/drawingml/2006/main">
             <a:r>
-              <a:t>0–25 seconds. Imagine your group project is due tomorrow. The group chat is active, but nobody owns the slides. The student coordinating the team has to chase people or finish the missing work. Fairshare is for that coordinator: a draft plan with a named owner and date for every task.</a:t>
+              <a:t>0–25 seconds. The deadline is tomorrow. Your group chat is busy, but nobody owns the slides. The student coordinating the project ends up chasing teammates or doing the missing work. Fairshare gives that coordinator a starting plan with an owner and date for every task.</a:t>
             </a:r>
           </a:p>
           <a:p xmlns:a="http://schemas.openxmlformats.org/drawingml/2006/main">
@@ -454,7 +454,7 @@
           </a:p>
           <a:p xmlns:a="http://schemas.openxmlformats.org/drawingml/2006/main">
             <a:r>
-              <a:t>The scenario and cost are hypotheses, not a participant quote or a measured result. Based on the owner-provided assignment and product mechanism.</a:t>
+              <a:t>The scenario illustrates the proposed customer problem. Time savings have not been measured.</a:t>
             </a:r>
           </a:p>
         </p:txBody>
@@ -524,7 +524,7 @@
           <a:lstStyle xmlns:a="http://schemas.openxmlformats.org/drawingml/2006/main"/>
           <a:p xmlns:a="http://schemas.openxmlformats.org/drawingml/2006/main">
             <a:r>
-              <a:t>25–60 seconds, including a 15-second live demonstration. Here is the working planner. Estimated hours guide the assignments. I can change an owner, see the workload change, then copy the plan into the team’s existing chat. The team still decides whether the assignments and dates make sense.</a:t>
+              <a:t>25–60 seconds, including a 15-second demonstration. Enter tasks, estimated hours, teammates, and a deadline. Fairshare distributes work using estimated hours. Here, I generate the plan, change an owner, watch workload totals update, and copy it into the team’s existing chat. The team must check availability and whether the dates make sense.</a:t>
             </a:r>
           </a:p>
           <a:p xmlns:a="http://schemas.openxmlformats.org/drawingml/2006/main">
@@ -534,7 +534,7 @@
           </a:p>
           <a:p xmlns:a="http://schemas.openxmlformats.org/drawingml/2006/main">
             <a:r>
-              <a:t>DEMO: Switch to the live site with the sample inputs prepared. Click Build my plan to demonstrate allocation. Move Research customer needs from Sam to Alex, show 5h/1h/3h, then click Copy for group chat. Do not paste or send to a real group during the pitch. Return to slide 3 by 60 seconds.</a:t>
+              <a:t>DEMO: Open the live site with sample inputs prepared. Click Build my plan. Move Research customer needs from Sam to Alex, show 5h/1h/3h, then click Copy for group chat. Do not send the sample to a real group.</a:t>
             </a:r>
           </a:p>
           <a:p xmlns:a="http://schemas.openxmlformats.org/drawingml/2006/main">
@@ -544,7 +544,7 @@
           </a:p>
           <a:p xmlns:a="http://schemas.openxmlformats.org/drawingml/2006/main">
             <a:r>
-              <a:t>Native table reproduces the deterministic sample output from planner.js; demonstration data, not user evidence. Live product: https://vestigeclub.github.io/VentureMVP/.</a:t>
+              <a:t>The table is sample output, not participant evidence. Live product: https://vestigeclub.github.io/VentureMVP/. Sample dates are illustrative and the live sample uses the current date.</a:t>
             </a:r>
           </a:p>
         </p:txBody>
@@ -614,7 +614,7 @@
           <a:lstStyle xmlns:a="http://schemas.openxmlformats.org/drawingml/2006/main"/>
           <a:p xmlns:a="http://schemas.openxmlformats.org/drawingml/2006/main">
             <a:r>
-              <a:t>60–90 seconds. The planner is free. The proposed payer is the coordinator buying a five-dollar human review for the team, before dividing the remaining work. That price is untested. My first test is whether two of three students voluntarily put a plan into their real team workflow. If they do not, I will revise the workflow before building the paid service.</a:t>
+              <a:t>60–90 seconds. The planner is free. I propose a five-dollar human review, paid by the coordinator, to check the task list against the assignment brief, flag missing work, and suggest assignments based on availability. That service is not available yet, and payment demand is untested. First, I am testing whether students voluntarily use the plan in their real group workflow.</a:t>
             </a:r>
           </a:p>
           <a:p xmlns:a="http://schemas.openxmlformats.org/drawingml/2006/main">
@@ -624,7 +624,7 @@
           </a:p>
           <a:p xmlns:a="http://schemas.openxmlformats.org/drawingml/2006/main">
             <a:r>
-              <a:t>No tests, sales, or practice pitch have happened yet. H1 v2 is precommitted in EXPERIMENT.md. Pricing and costs are assumptions in ECONOMICS.md. The actual practice feedback must guide the claim revision for the graded re-pitch.</a:t>
+              <a:t>One friend informally tested Fairshare for a group project, as reported by the owner. The formal H1 study remains incomplete. See docs/coursework/experiment.md and docs/coursework/economics.md in the repository.</a:t>
             </a:r>
           </a:p>
         </p:txBody>
@@ -692,7 +692,7 @@
   </p:cSld>
   <p:clrMap bg1="lt1" tx1="dk1" bg2="lt2" tx2="dk2" accent1="accent1" accent2="accent2" accent3="accent3" accent4="accent4" accent5="accent5" accent6="accent6" hlink="hlink" folHlink="folHlink"/>
   <p:sldLayoutIdLst>
-    <p:sldLayoutId xmlns:r="http://schemas.openxmlformats.org/officeDocument/2006/relationships" id="2147483649" r:id="Rb48d7e6de4b34fd3"/>
+    <p:sldLayoutId xmlns:r="http://schemas.openxmlformats.org/officeDocument/2006/relationships" id="2147483649" r:id="R06c82f12d7f34ca4"/>
   </p:sldLayoutIdLst>
   <p:txStyles>
     <p:titleStyle>
@@ -1243,7 +1243,7 @@
           <p:cNvPr id="5" name="">
             <a:extLst xmlns:a="http://schemas.openxmlformats.org/drawingml/2006/main">
               <a:ext uri="{FF2B5EF4-FFF2-40B4-BE49-F238E27FC236}">
-                <a16:creationId xmlns:a16="http://schemas.microsoft.com/office/drawing/2014/main" id="{F2902B93-1D4B-4864-8AF2-DE113686EB6B}"/>
+                <a16:creationId xmlns:a16="http://schemas.microsoft.com/office/drawing/2014/main" id="{C301DA46-74CF-4405-B1DE-BD67A5A1754F}"/>
               </a:ext>
             </a:extLst>
           </p:cNvPr>
@@ -1300,7 +1300,7 @@
           <p:cNvPr id="2" name="">
             <a:extLst xmlns:a="http://schemas.openxmlformats.org/drawingml/2006/main">
               <a:ext uri="{FF2B5EF4-FFF2-40B4-BE49-F238E27FC236}">
-                <a16:creationId xmlns:a16="http://schemas.microsoft.com/office/drawing/2014/main" id="{27735313-B60D-4B4B-9C7E-0364B43E545A}"/>
+                <a16:creationId xmlns:a16="http://schemas.microsoft.com/office/drawing/2014/main" id="{742BE935-6791-4B80-8030-59C94A6C52DA}"/>
               </a:ext>
             </a:extLst>
           </p:cNvPr>
@@ -1380,7 +1380,7 @@
           <p:cNvPr id="3" name="">
             <a:extLst xmlns:a="http://schemas.openxmlformats.org/drawingml/2006/main">
               <a:ext uri="{FF2B5EF4-FFF2-40B4-BE49-F238E27FC236}">
-                <a16:creationId xmlns:a16="http://schemas.microsoft.com/office/drawing/2014/main" id="{C7003143-7699-43EC-B2B0-A63A7998F77F}"/>
+                <a16:creationId xmlns:a16="http://schemas.microsoft.com/office/drawing/2014/main" id="{288AAEE7-911E-4F63-AE87-8BFB7AA67C7E}"/>
               </a:ext>
             </a:extLst>
           </p:cNvPr>
@@ -1460,7 +1460,7 @@
           <p:cNvPr id="4" name="">
             <a:extLst xmlns:a="http://schemas.openxmlformats.org/drawingml/2006/main">
               <a:ext uri="{FF2B5EF4-FFF2-40B4-BE49-F238E27FC236}">
-                <a16:creationId xmlns:a16="http://schemas.microsoft.com/office/drawing/2014/main" id="{818C87AA-5091-489D-8CCE-88F1CC584880}"/>
+                <a16:creationId xmlns:a16="http://schemas.microsoft.com/office/drawing/2014/main" id="{295E0981-E0A8-4016-8F61-B871BC9B68E7}"/>
               </a:ext>
             </a:extLst>
           </p:cNvPr>
@@ -1515,7 +1515,7 @@
     </p:spTree>
     <p:extLst>
       <p:ext uri="{BB962C8B-B14F-4D97-AF65-F5344CB8AC3E}">
-        <p14:creationId xmlns:p14="http://schemas.microsoft.com/office/powerpoint/2010/main" val="277317244"/>
+        <p14:creationId xmlns:p14="http://schemas.microsoft.com/office/powerpoint/2010/main" val="729703257"/>
       </p:ext>
     </p:extLst>
   </p:cSld>
@@ -1546,7 +1546,7 @@
           <p:cNvPr id="6" name="">
             <a:extLst xmlns:a="http://schemas.openxmlformats.org/drawingml/2006/main">
               <a:ext uri="{FF2B5EF4-FFF2-40B4-BE49-F238E27FC236}">
-                <a16:creationId xmlns:a16="http://schemas.microsoft.com/office/drawing/2014/main" id="{BF7ECE12-F57E-41CA-903B-B0670FEFFDDF}"/>
+                <a16:creationId xmlns:a16="http://schemas.microsoft.com/office/drawing/2014/main" id="{C34C5CCC-D373-446B-AA47-2AB390EB4AC1}"/>
               </a:ext>
             </a:extLst>
           </p:cNvPr>
@@ -1603,7 +1603,7 @@
           <p:cNvPr id="2" name="">
             <a:extLst xmlns:a="http://schemas.openxmlformats.org/drawingml/2006/main">
               <a:ext uri="{FF2B5EF4-FFF2-40B4-BE49-F238E27FC236}">
-                <a16:creationId xmlns:a16="http://schemas.microsoft.com/office/drawing/2014/main" id="{C4113FFA-9B71-4909-A6B4-7A564671E30F}"/>
+                <a16:creationId xmlns:a16="http://schemas.microsoft.com/office/drawing/2014/main" id="{05C856FA-AB71-4A0D-A1AE-89D4DF355C9B}"/>
               </a:ext>
             </a:extLst>
           </p:cNvPr>
@@ -2272,7 +2272,7 @@
           <p:cNvPr id="4" name="">
             <a:extLst xmlns:a="http://schemas.openxmlformats.org/drawingml/2006/main">
               <a:ext uri="{FF2B5EF4-FFF2-40B4-BE49-F238E27FC236}">
-                <a16:creationId xmlns:a16="http://schemas.microsoft.com/office/drawing/2014/main" id="{635694B4-EC4E-4C94-BB1B-583F1D6BE929}"/>
+                <a16:creationId xmlns:a16="http://schemas.microsoft.com/office/drawing/2014/main" id="{055CE7D9-6852-4ADD-8F14-19124BEB0B0F}"/>
               </a:ext>
             </a:extLst>
           </p:cNvPr>
@@ -2329,7 +2329,7 @@
           <p:cNvPr id="5" name="">
             <a:extLst xmlns:a="http://schemas.openxmlformats.org/drawingml/2006/main">
               <a:ext uri="{FF2B5EF4-FFF2-40B4-BE49-F238E27FC236}">
-                <a16:creationId xmlns:a16="http://schemas.microsoft.com/office/drawing/2014/main" id="{4DCFCA79-A27C-4DB8-B1E5-F8BAD6A1B1E2}"/>
+                <a16:creationId xmlns:a16="http://schemas.microsoft.com/office/drawing/2014/main" id="{2336B21D-DF73-43EE-8E82-51865FB261C0}"/>
               </a:ext>
             </a:extLst>
           </p:cNvPr>
@@ -2384,7 +2384,7 @@
     </p:spTree>
     <p:extLst>
       <p:ext uri="{BB962C8B-B14F-4D97-AF65-F5344CB8AC3E}">
-        <p14:creationId xmlns:p14="http://schemas.microsoft.com/office/powerpoint/2010/main" val="443618437"/>
+        <p14:creationId xmlns:p14="http://schemas.microsoft.com/office/powerpoint/2010/main" val="1877520083"/>
       </p:ext>
     </p:extLst>
   </p:cSld>
@@ -2415,7 +2415,7 @@
           <p:cNvPr id="7" name="">
             <a:extLst xmlns:a="http://schemas.openxmlformats.org/drawingml/2006/main">
               <a:ext uri="{FF2B5EF4-FFF2-40B4-BE49-F238E27FC236}">
-                <a16:creationId xmlns:a16="http://schemas.microsoft.com/office/drawing/2014/main" id="{E0BED3E9-8FF2-41BA-B6CC-569F9C65D2CF}"/>
+                <a16:creationId xmlns:a16="http://schemas.microsoft.com/office/drawing/2014/main" id="{EBD08A29-E570-45AA-B44F-4D16319A066F}"/>
               </a:ext>
             </a:extLst>
           </p:cNvPr>
@@ -2472,7 +2472,7 @@
           <p:cNvPr id="2" name="">
             <a:extLst xmlns:a="http://schemas.openxmlformats.org/drawingml/2006/main">
               <a:ext uri="{FF2B5EF4-FFF2-40B4-BE49-F238E27FC236}">
-                <a16:creationId xmlns:a16="http://schemas.microsoft.com/office/drawing/2014/main" id="{53EFFC40-0CF8-406F-920F-334DBC74EB41}"/>
+                <a16:creationId xmlns:a16="http://schemas.microsoft.com/office/drawing/2014/main" id="{00FDE3C4-28DD-43F3-8BA5-8DE99ADCD6BA}"/>
               </a:ext>
             </a:extLst>
           </p:cNvPr>
@@ -2529,7 +2529,7 @@
           <p:cNvPr id="3" name="">
             <a:extLst xmlns:a="http://schemas.openxmlformats.org/drawingml/2006/main">
               <a:ext uri="{FF2B5EF4-FFF2-40B4-BE49-F238E27FC236}">
-                <a16:creationId xmlns:a16="http://schemas.microsoft.com/office/drawing/2014/main" id="{6EA6A630-C9D6-44E3-B18A-0F04DE030237}"/>
+                <a16:creationId xmlns:a16="http://schemas.microsoft.com/office/drawing/2014/main" id="{BFB22E3E-E37C-4D39-8AA7-04B85D7A1A49}"/>
               </a:ext>
             </a:extLst>
           </p:cNvPr>
@@ -2609,7 +2609,7 @@
           <p:cNvPr id="4" name="">
             <a:extLst xmlns:a="http://schemas.openxmlformats.org/drawingml/2006/main">
               <a:ext uri="{FF2B5EF4-FFF2-40B4-BE49-F238E27FC236}">
-                <a16:creationId xmlns:a16="http://schemas.microsoft.com/office/drawing/2014/main" id="{ACD8A4F8-C2C2-4456-BBC9-981A480B5B8A}"/>
+                <a16:creationId xmlns:a16="http://schemas.microsoft.com/office/drawing/2014/main" id="{17A95473-389E-4741-9453-4CA6D3ABDF03}"/>
               </a:ext>
             </a:extLst>
           </p:cNvPr>
@@ -2621,7 +2621,7 @@
         <p:spPr>
           <a:xfrm xmlns:a="http://schemas.openxmlformats.org/drawingml/2006/main">
             <a:off x="6229350" y="1771650"/>
-            <a:ext cx="5238750" cy="952500"/>
+            <a:ext cx="5238750" cy="1285875"/>
           </a:xfrm>
           <a:prstGeom xmlns:a="http://schemas.openxmlformats.org/drawingml/2006/main" prst="rect">
             <a:avLst/>
@@ -2638,7 +2638,7 @@
           <a:lstStyle xmlns:a="http://schemas.openxmlformats.org/drawingml/2006/main"/>
           <a:p xmlns:a="http://schemas.openxmlformats.org/drawingml/2006/main">
             <a:pPr>
-              <a:defRPr sz="2400" b="0">
+              <a:defRPr sz="2250" b="0">
                 <a:solidFill>
                   <a:srgbClr val="17191F"/>
                 </a:solidFill>
@@ -2648,7 +2648,7 @@
               </a:defRPr>
             </a:pPr>
             <a:r>
-              <a:rPr sz="2400" b="0">
+              <a:rPr sz="2250" b="0">
                 <a:solidFill>
                   <a:srgbClr val="17191F"/>
                 </a:solidFill>
@@ -2656,12 +2656,12 @@
                 <a:ea typeface="Helvetica Neue"/>
                 <a:cs typeface="Helvetica Neue"/>
               </a:rPr>
-              <a:t>One student would pay for a review</a:t>
+              <a:t>Check the assignment brief.</a:t>
             </a:r>
           </a:p>
           <a:p xmlns:a="http://schemas.openxmlformats.org/drawingml/2006/main">
             <a:pPr>
-              <a:defRPr sz="2400" b="0">
+              <a:defRPr sz="2250" b="0">
                 <a:solidFill>
                   <a:srgbClr val="17191F"/>
                 </a:solidFill>
@@ -2671,7 +2671,7 @@
               </a:defRPr>
             </a:pPr>
             <a:r>
-              <a:rPr sz="2400" b="0">
+              <a:rPr sz="2250" b="0">
                 <a:solidFill>
                   <a:srgbClr val="17191F"/>
                 </a:solidFill>
@@ -2679,7 +2679,30 @@
                 <a:ea typeface="Helvetica Neue"/>
                 <a:cs typeface="Helvetica Neue"/>
               </a:rPr>
-              <a:t>the whole team can use.</a:t>
+              <a:t>Flag missing tasks.</a:t>
+            </a:r>
+          </a:p>
+          <a:p xmlns:a="http://schemas.openxmlformats.org/drawingml/2006/main">
+            <a:pPr>
+              <a:defRPr sz="2250" b="0">
+                <a:solidFill>
+                  <a:srgbClr val="17191F"/>
+                </a:solidFill>
+                <a:latin typeface="Helvetica Neue"/>
+                <a:ea typeface="Helvetica Neue"/>
+                <a:cs typeface="Helvetica Neue"/>
+              </a:defRPr>
+            </a:pPr>
+            <a:r>
+              <a:rPr sz="2250" b="0">
+                <a:solidFill>
+                  <a:srgbClr val="17191F"/>
+                </a:solidFill>
+                <a:latin typeface="Helvetica Neue"/>
+                <a:ea typeface="Helvetica Neue"/>
+                <a:cs typeface="Helvetica Neue"/>
+              </a:rPr>
+              <a:t>Consider teammate availability.</a:t>
             </a:r>
           </a:p>
         </p:txBody>
@@ -2689,7 +2712,7 @@
           <p:cNvPr id="5" name="">
             <a:extLst xmlns:a="http://schemas.openxmlformats.org/drawingml/2006/main">
               <a:ext uri="{FF2B5EF4-FFF2-40B4-BE49-F238E27FC236}">
-                <a16:creationId xmlns:a16="http://schemas.microsoft.com/office/drawing/2014/main" id="{7868CCE2-DB89-4B68-BCD8-AC0DE4707097}"/>
+                <a16:creationId xmlns:a16="http://schemas.microsoft.com/office/drawing/2014/main" id="{42823CAA-0AE5-48BE-9F88-F4B4CE898267}"/>
               </a:ext>
             </a:extLst>
           </p:cNvPr>
@@ -2792,7 +2815,7 @@
           <p:cNvPr id="6" name="">
             <a:extLst xmlns:a="http://schemas.openxmlformats.org/drawingml/2006/main">
               <a:ext uri="{FF2B5EF4-FFF2-40B4-BE49-F238E27FC236}">
-                <a16:creationId xmlns:a16="http://schemas.microsoft.com/office/drawing/2014/main" id="{791CB3D1-F080-4C76-8C81-434943C57416}"/>
+                <a16:creationId xmlns:a16="http://schemas.microsoft.com/office/drawing/2014/main" id="{4459C296-F6A5-457F-AFC6-7FF3C15B984F}"/>
               </a:ext>
             </a:extLst>
           </p:cNvPr>
@@ -2847,7 +2870,7 @@
     </p:spTree>
     <p:extLst>
       <p:ext uri="{BB962C8B-B14F-4D97-AF65-F5344CB8AC3E}">
-        <p14:creationId xmlns:p14="http://schemas.microsoft.com/office/powerpoint/2010/main" val="674561861"/>
+        <p14:creationId xmlns:p14="http://schemas.microsoft.com/office/powerpoint/2010/main" val="416134328"/>
       </p:ext>
     </p:extLst>
   </p:cSld>

</xml_diff>